<commit_message>
Ajout des livrables de soutenance et documents organisation Quentin Dumas.
Co-authored-by: Cursor <cursoragent@cursor.com>
</commit_message>
<xml_diff>
--- a/Projet/FlowLearn_Soutenance.pptx
+++ b/Projet/FlowLearn_Soutenance.pptx
@@ -21612,9 +21612,6 @@
           <a:bodyPr wrap="square" lIns="0" tIns="0" rIns="0" bIns="0" rtlCol="0" anchor="ctr"/>
           <a:lstStyle/>
           <a:p>
-            <a:pPr marL="0" indent="0">
-              <a:buNone/>
-            </a:pPr>
             <a:r>
               <a:rPr lang="en-US" sz="1100" dirty="0">
                 <a:solidFill>
@@ -21624,7 +21621,7 @@
                 <a:ea typeface="Inter" pitchFamily="34" charset="-122"/>
                 <a:cs typeface="Inter" pitchFamily="34" charset="-120"/>
               </a:rPr>
-              <a:t>Desktop, mobile, vocal, IoT — extensible par la communauté.</a:t>
+              <a:t>Mobile, desktop, vocal, IoT — extensible par la communauté.</a:t>
             </a:r>
             <a:endParaRPr lang="en-US" sz="1100" dirty="0"/>
           </a:p>
@@ -21877,209 +21874,6 @@
       </p:sp>
       <p:sp>
         <p:nvSpPr>
-          <p:cNvPr id="4" name="Shape 2"/>
-          <p:cNvSpPr/>
-          <p:nvPr/>
-        </p:nvSpPr>
-        <p:spPr>
-          <a:xfrm>
-            <a:off x="722376" y="1728216"/>
-            <a:ext cx="5321808" cy="3914166"/>
-          </a:xfrm>
-          <a:prstGeom prst="roundRect">
-            <a:avLst>
-              <a:gd name="adj" fmla="val 1869"/>
-            </a:avLst>
-          </a:prstGeom>
-          <a:solidFill>
-            <a:srgbClr val="0F172A"/>
-          </a:solidFill>
-          <a:ln/>
-          <a:effectLst>
-            <a:outerShdw blurRad="114300" dist="38100" dir="5400000" algn="bl" rotWithShape="0">
-              <a:srgbClr val="000000">
-                <a:alpha val="22000"/>
-              </a:srgbClr>
-            </a:outerShdw>
-          </a:effectLst>
-        </p:spPr>
-        <p:txBody>
-          <a:bodyPr/>
-          <a:lstStyle/>
-          <a:p>
-            <a:endParaRPr lang="en-US"/>
-          </a:p>
-        </p:txBody>
-      </p:sp>
-      <p:pic>
-        <p:nvPicPr>
-          <p:cNvPr id="5" name="Image 0" descr="/home/claude/dash_dark.png"/>
-          <p:cNvPicPr>
-            <a:picLocks noChangeAspect="1"/>
-          </p:cNvPicPr>
-          <p:nvPr/>
-        </p:nvPicPr>
-        <p:blipFill>
-          <a:blip r:embed="rId3"/>
-          <a:stretch>
-            <a:fillRect/>
-          </a:stretch>
-        </p:blipFill>
-        <p:spPr>
-          <a:xfrm>
-            <a:off x="777240" y="1783080"/>
-            <a:ext cx="5212080" cy="3804438"/>
-          </a:xfrm>
-          <a:prstGeom prst="rect">
-            <a:avLst/>
-          </a:prstGeom>
-        </p:spPr>
-      </p:pic>
-      <p:sp>
-        <p:nvSpPr>
-          <p:cNvPr id="6" name="Text 3"/>
-          <p:cNvSpPr/>
-          <p:nvPr/>
-        </p:nvSpPr>
-        <p:spPr>
-          <a:xfrm>
-            <a:off x="777240" y="5660670"/>
-            <a:ext cx="5212080" cy="274320"/>
-          </a:xfrm>
-          <a:prstGeom prst="rect">
-            <a:avLst/>
-          </a:prstGeom>
-          <a:noFill/>
-          <a:ln/>
-        </p:spPr>
-        <p:txBody>
-          <a:bodyPr wrap="square" lIns="0" tIns="0" rIns="0" bIns="0" rtlCol="0" anchor="ctr"/>
-          <a:lstStyle/>
-          <a:p>
-            <a:pPr marL="0" indent="0" algn="ctr">
-              <a:buNone/>
-            </a:pPr>
-            <a:r>
-              <a:rPr lang="en-US" sz="1100" b="1" dirty="0">
-                <a:solidFill>
-                  <a:srgbClr val="64748B"/>
-                </a:solidFill>
-                <a:latin typeface="Inter" pitchFamily="34" charset="0"/>
-                <a:ea typeface="Inter" pitchFamily="34" charset="-122"/>
-                <a:cs typeface="Inter" pitchFamily="34" charset="-120"/>
-              </a:rPr>
-              <a:t>L'application — dashboard</a:t>
-            </a:r>
-            <a:endParaRPr lang="en-US" sz="1100" dirty="0"/>
-          </a:p>
-        </p:txBody>
-      </p:sp>
-      <p:sp>
-        <p:nvSpPr>
-          <p:cNvPr id="7" name="Shape 4"/>
-          <p:cNvSpPr/>
-          <p:nvPr/>
-        </p:nvSpPr>
-        <p:spPr>
-          <a:xfrm>
-            <a:off x="6208776" y="1728216"/>
-            <a:ext cx="2734790" cy="3914166"/>
-          </a:xfrm>
-          <a:prstGeom prst="roundRect">
-            <a:avLst>
-              <a:gd name="adj" fmla="val 2675"/>
-            </a:avLst>
-          </a:prstGeom>
-          <a:solidFill>
-            <a:srgbClr val="FFFFFF"/>
-          </a:solidFill>
-          <a:ln w="12700">
-            <a:solidFill>
-              <a:srgbClr val="E2E8F0"/>
-            </a:solidFill>
-            <a:prstDash val="solid"/>
-          </a:ln>
-          <a:effectLst>
-            <a:outerShdw blurRad="114300" dist="38100" dir="5400000" algn="bl" rotWithShape="0">
-              <a:srgbClr val="000000">
-                <a:alpha val="18000"/>
-              </a:srgbClr>
-            </a:outerShdw>
-          </a:effectLst>
-        </p:spPr>
-        <p:txBody>
-          <a:bodyPr/>
-          <a:lstStyle/>
-          <a:p>
-            <a:endParaRPr lang="en-US"/>
-          </a:p>
-        </p:txBody>
-      </p:sp>
-      <p:pic>
-        <p:nvPicPr>
-          <p:cNvPr id="8" name="Image 1" descr="/home/claude/landing.png"/>
-          <p:cNvPicPr>
-            <a:picLocks noChangeAspect="1"/>
-          </p:cNvPicPr>
-          <p:nvPr/>
-        </p:nvPicPr>
-        <p:blipFill>
-          <a:blip r:embed="rId4"/>
-          <a:stretch>
-            <a:fillRect/>
-          </a:stretch>
-        </p:blipFill>
-        <p:spPr>
-          <a:xfrm>
-            <a:off x="6263640" y="1783080"/>
-            <a:ext cx="2625062" cy="3804438"/>
-          </a:xfrm>
-          <a:prstGeom prst="rect">
-            <a:avLst/>
-          </a:prstGeom>
-        </p:spPr>
-      </p:pic>
-      <p:sp>
-        <p:nvSpPr>
-          <p:cNvPr id="9" name="Text 5"/>
-          <p:cNvSpPr/>
-          <p:nvPr/>
-        </p:nvSpPr>
-        <p:spPr>
-          <a:xfrm>
-            <a:off x="6263640" y="5660670"/>
-            <a:ext cx="2625062" cy="274320"/>
-          </a:xfrm>
-          <a:prstGeom prst="rect">
-            <a:avLst/>
-          </a:prstGeom>
-          <a:noFill/>
-          <a:ln/>
-        </p:spPr>
-        <p:txBody>
-          <a:bodyPr wrap="square" lIns="0" tIns="0" rIns="0" bIns="0" rtlCol="0" anchor="ctr"/>
-          <a:lstStyle/>
-          <a:p>
-            <a:pPr marL="0" indent="0" algn="ctr">
-              <a:buNone/>
-            </a:pPr>
-            <a:r>
-              <a:rPr lang="en-US" sz="1100" b="1" dirty="0">
-                <a:solidFill>
-                  <a:srgbClr val="64748B"/>
-                </a:solidFill>
-                <a:latin typeface="Inter" pitchFamily="34" charset="0"/>
-                <a:ea typeface="Inter" pitchFamily="34" charset="-122"/>
-                <a:cs typeface="Inter" pitchFamily="34" charset="-120"/>
-              </a:rPr>
-              <a:t>La landing publique</a:t>
-            </a:r>
-            <a:endParaRPr lang="en-US" sz="1100" dirty="0"/>
-          </a:p>
-        </p:txBody>
-      </p:sp>
-      <p:sp>
-        <p:nvSpPr>
           <p:cNvPr id="10" name="Text 6"/>
           <p:cNvSpPr/>
           <p:nvPr/>
@@ -22802,6 +22596,154 @@
             <a:r>
               <a:rPr lang="en-US" sz="1200" dirty="0"/>
               <a:t>Luca</a:t>
+            </a:r>
+          </a:p>
+        </p:txBody>
+      </p:sp>
+      <p:pic>
+        <p:nvPicPr>
+          <p:cNvPr id="32" name="Image 2" descr="/home/claude/logo_color.png">
+            <a:extLst>
+              <a:ext uri="{FF2B5EF4-FFF2-40B4-BE49-F238E27FC236}">
+                <a16:creationId xmlns:a16="http://schemas.microsoft.com/office/drawing/2014/main" id="{DA1FD55B-CF45-0DEB-A86A-E7DE338F51DF}"/>
+              </a:ext>
+            </a:extLst>
+          </p:cNvPr>
+          <p:cNvPicPr>
+            <a:picLocks noChangeAspect="1"/>
+          </p:cNvPicPr>
+          <p:nvPr/>
+        </p:nvPicPr>
+        <p:blipFill>
+          <a:blip r:embed="rId9"/>
+          <a:stretch>
+            <a:fillRect/>
+          </a:stretch>
+        </p:blipFill>
+        <p:spPr>
+          <a:xfrm>
+            <a:off x="5341366" y="206883"/>
+            <a:ext cx="1295908" cy="1295908"/>
+          </a:xfrm>
+          <a:prstGeom prst="rect">
+            <a:avLst/>
+          </a:prstGeom>
+        </p:spPr>
+      </p:pic>
+      <p:pic>
+        <p:nvPicPr>
+          <p:cNvPr id="33" name="Picture 32" descr="laptop_dash.png"/>
+          <p:cNvPicPr>
+            <a:picLocks noChangeAspect="1"/>
+          </p:cNvPicPr>
+          <p:nvPr/>
+        </p:nvPicPr>
+        <p:blipFill>
+          <a:blip r:embed="rId10"/>
+          <a:stretch>
+            <a:fillRect/>
+          </a:stretch>
+        </p:blipFill>
+        <p:spPr>
+          <a:xfrm>
+            <a:off x="640080" y="2121408"/>
+            <a:ext cx="5394960" cy="3376070"/>
+          </a:xfrm>
+          <a:prstGeom prst="rect">
+            <a:avLst/>
+          </a:prstGeom>
+        </p:spPr>
+      </p:pic>
+      <p:pic>
+        <p:nvPicPr>
+          <p:cNvPr id="34" name="Picture 33" descr="phone_landing.png"/>
+          <p:cNvPicPr>
+            <a:picLocks noChangeAspect="1"/>
+          </p:cNvPicPr>
+          <p:nvPr/>
+        </p:nvPicPr>
+        <p:blipFill>
+          <a:blip r:embed="rId11"/>
+          <a:stretch>
+            <a:fillRect/>
+          </a:stretch>
+        </p:blipFill>
+        <p:spPr>
+          <a:xfrm>
+            <a:off x="6144768" y="1572768"/>
+            <a:ext cx="2102361" cy="4050791"/>
+          </a:xfrm>
+          <a:prstGeom prst="rect">
+            <a:avLst/>
+          </a:prstGeom>
+        </p:spPr>
+      </p:pic>
+      <p:sp>
+        <p:nvSpPr>
+          <p:cNvPr id="35" name="TextBox 34"/>
+          <p:cNvSpPr txBox="1"/>
+          <p:nvPr/>
+        </p:nvSpPr>
+        <p:spPr>
+          <a:xfrm>
+            <a:off x="640080" y="5559552"/>
+            <a:ext cx="5394960" cy="274320"/>
+          </a:xfrm>
+          <a:prstGeom prst="rect">
+            <a:avLst/>
+          </a:prstGeom>
+          <a:noFill/>
+        </p:spPr>
+        <p:txBody>
+          <a:bodyPr wrap="square" lIns="0" rIns="0" tIns="0" bIns="0">
+            <a:spAutoFit/>
+          </a:bodyPr>
+          <a:lstStyle/>
+          <a:p>
+            <a:pPr algn="ctr"/>
+            <a:r>
+              <a:rPr sz="1100" b="1">
+                <a:solidFill>
+                  <a:srgbClr val="94A3B8"/>
+                </a:solidFill>
+                <a:latin typeface="Inter"/>
+              </a:rPr>
+              <a:t>Le dashboard — sur navigateur</a:t>
+            </a:r>
+          </a:p>
+        </p:txBody>
+      </p:sp>
+      <p:sp>
+        <p:nvSpPr>
+          <p:cNvPr id="36" name="TextBox 35"/>
+          <p:cNvSpPr txBox="1"/>
+          <p:nvPr/>
+        </p:nvSpPr>
+        <p:spPr>
+          <a:xfrm>
+            <a:off x="5852160" y="5687568"/>
+            <a:ext cx="2651760" cy="274320"/>
+          </a:xfrm>
+          <a:prstGeom prst="rect">
+            <a:avLst/>
+          </a:prstGeom>
+          <a:noFill/>
+        </p:spPr>
+        <p:txBody>
+          <a:bodyPr wrap="square" lIns="0" rIns="0" tIns="0" bIns="0">
+            <a:spAutoFit/>
+          </a:bodyPr>
+          <a:lstStyle/>
+          <a:p>
+            <a:pPr algn="ctr"/>
+            <a:r>
+              <a:rPr sz="1100" b="1">
+                <a:solidFill>
+                  <a:srgbClr val="94A3B8"/>
+                </a:solidFill>
+                <a:latin typeface="Inter"/>
+              </a:rPr>
+              <a:t>La landing — sur mobile</a:t>
             </a:r>
           </a:p>
         </p:txBody>
@@ -24061,40 +24003,6 @@
       </p:sp>
       <p:sp>
         <p:nvSpPr>
-          <p:cNvPr id="22" name="Shape 19"/>
-          <p:cNvSpPr/>
-          <p:nvPr/>
-        </p:nvSpPr>
-        <p:spPr>
-          <a:xfrm>
-            <a:off x="2286000" y="5797296"/>
-            <a:ext cx="2697480" cy="420624"/>
-          </a:xfrm>
-          <a:prstGeom prst="roundRect">
-            <a:avLst>
-              <a:gd name="adj" fmla="val 13043"/>
-            </a:avLst>
-          </a:prstGeom>
-          <a:solidFill>
-            <a:srgbClr val="F8FAFC"/>
-          </a:solidFill>
-          <a:ln w="12700">
-            <a:solidFill>
-              <a:srgbClr val="E2E8F0"/>
-            </a:solidFill>
-            <a:prstDash val="solid"/>
-          </a:ln>
-        </p:spPr>
-        <p:txBody>
-          <a:bodyPr/>
-          <a:lstStyle/>
-          <a:p>
-            <a:endParaRPr lang="en-US"/>
-          </a:p>
-        </p:txBody>
-      </p:sp>
-      <p:sp>
-        <p:nvSpPr>
           <p:cNvPr id="23" name="Text 20"/>
           <p:cNvSpPr/>
           <p:nvPr/>
@@ -24117,28 +24025,6 @@
             <a:pPr marL="0" indent="0">
               <a:buNone/>
             </a:pPr>
-            <a:r>
-              <a:rPr lang="en-US" sz="1150" b="1" dirty="0">
-                <a:solidFill>
-                  <a:srgbClr val="0F172A"/>
-                </a:solidFill>
-                <a:latin typeface="Inter" pitchFamily="34" charset="0"/>
-                <a:ea typeface="Inter" pitchFamily="34" charset="-122"/>
-                <a:cs typeface="Inter" pitchFamily="34" charset="-120"/>
-              </a:rPr>
-              <a:t>César Lextraît  </a:t>
-            </a:r>
-            <a:r>
-              <a:rPr lang="en-US" sz="1050" dirty="0">
-                <a:solidFill>
-                  <a:srgbClr val="64748B"/>
-                </a:solidFill>
-                <a:latin typeface="Inter" pitchFamily="34" charset="0"/>
-                <a:ea typeface="Inter" pitchFamily="34" charset="-122"/>
-                <a:cs typeface="Inter" pitchFamily="34" charset="-120"/>
-              </a:rPr>
-              <a:t>· Dev (partiel)</a:t>
-            </a:r>
             <a:endParaRPr lang="en-US" sz="1150" dirty="0"/>
           </a:p>
         </p:txBody>

</xml_diff>